<commit_message>
Update complete travel website
</commit_message>
<xml_diff>
--- a/downloads/ollie-media-kit.pptx
+++ b/downloads/ollie-media-kit.pptx
@@ -1520,7 +1520,7 @@
                   <a:srgbClr val="15323B"/>
                 </a:solidFill>
               </a:rPr>
-              <a:t>STEADMAN</a:t>
+              <a:t/>
             </a:r>
           </a:p>
         </p:txBody>
@@ -1673,7 +1673,7 @@
                   <a:srgbClr val="176B87"/>
                 </a:solidFill>
               </a:rPr>
-              <a:t>6.66M Instagram views  •  90 days  •  11 Apr–9 Jul</a:t>
+              <a:t>7K+ combined followers  •  6.66M Instagram views  •  90 days</a:t>
             </a:r>
           </a:p>
         </p:txBody>

</xml_diff>

<commit_message>
Refine homepage, contact links, fundraising and activity widgets
</commit_message>
<xml_diff>
--- a/downloads/ollie-media-kit.pptx
+++ b/downloads/ollie-media-kit.pptx
@@ -1673,7 +1673,7 @@
                   <a:srgbClr val="176B87"/>
                 </a:solidFill>
               </a:rPr>
-              <a:t>7K+ combined followers  •  6.66M Instagram views  •  90 days</a:t>
+              <a:t>11K+ combined followers  •  6.66M Instagram views  •  90 days</a:t>
             </a:r>
           </a:p>
         </p:txBody>
@@ -1724,7 +1724,7 @@
                   <a:srgbClr val="5E7378"/>
                 </a:solidFill>
               </a:rPr>
-              <a:t>ollietype1travel@outlook.com</a:t>
+              <a:t>hello@ollietype1travel.com</a:t>
             </a:r>
           </a:p>
         </p:txBody>
@@ -3034,7 +3034,7 @@
                   <a:srgbClr val="176B87"/>
                 </a:solidFill>
               </a:rPr>
-              <a:t>ollietype1travel@outlook.com</a:t>
+              <a:t>hello@ollietype1travel.com</a:t>
             </a:r>
           </a:p>
         </p:txBody>
@@ -3085,7 +3085,7 @@
                   <a:srgbClr val="5E7378"/>
                 </a:solidFill>
               </a:rPr>
-              <a:t>Instagram @type1solotravel   •   TikTok @type1solotravel</a:t>
+              <a:t>Instagram @ollietype1travel   •   TikTok @ollietype1travel</a:t>
             </a:r>
           </a:p>
         </p:txBody>
@@ -7245,7 +7245,7 @@
                   <a:srgbClr val="176B87"/>
                 </a:solidFill>
               </a:rPr>
-              <a:t>ollietype1travel@outlook.com</a:t>
+              <a:t>hello@ollietype1travel.com</a:t>
             </a:r>
           </a:p>
         </p:txBody>
@@ -7296,7 +7296,7 @@
                   <a:srgbClr val="5E7378"/>
                 </a:solidFill>
               </a:rPr>
-              <a:t>Instagram @type1solotravel   •   TikTok @type1solotravel</a:t>
+              <a:t>Instagram @ollietype1travel   •   TikTok @ollietype1travel</a:t>
             </a:r>
           </a:p>
         </p:txBody>

</xml_diff>